<commit_message>
Upgrade AI Assistant with OpenAI API integration
</commit_message>
<xml_diff>
--- a/AI_Assistant_Presentation.pptx
+++ b/AI_Assistant_Presentation.pptx
@@ -121,7 +121,7 @@
 <file path=ppt/revisionInfo.xml><?xml version="1.0" encoding="utf-8"?>
 <p1510:revInfo xmlns:a="http://schemas.openxmlformats.org/drawingml/2006/main" xmlns:r="http://schemas.openxmlformats.org/officeDocument/2006/relationships" xmlns:p1510="http://schemas.microsoft.com/office/powerpoint/2015/10/main">
   <p1510:revLst>
-    <p1510:client id="{1B785FC4-F235-4D00-A968-0E035B4D2CCF}" v="14" dt="2026-06-08T15:43:37.609"/>
+    <p1510:client id="{167C7D98-A27D-4370-B7D7-E4E22F096D65}" v="3" dt="2026-06-19T15:15:08.947"/>
   </p1510:revLst>
 </p1510:revInfo>
 </file>
@@ -131,18 +131,18 @@
   <pc:docChgLst>
     <pc:chgData name="Sai Nikitha" userId="c9bca8b270492e35" providerId="LiveId" clId="{AABBDE1E-0FB9-4CB6-9955-FC440C73D552}"/>
     <pc:docChg chg="delSld modSld">
-      <pc:chgData name="Sai Nikitha" userId="c9bca8b270492e35" providerId="LiveId" clId="{AABBDE1E-0FB9-4CB6-9955-FC440C73D552}" dt="2026-06-08T15:45:03.585" v="246" actId="47"/>
+      <pc:chgData name="Sai Nikitha" userId="c9bca8b270492e35" providerId="LiveId" clId="{AABBDE1E-0FB9-4CB6-9955-FC440C73D552}" dt="2026-06-19T15:15:39.549" v="272" actId="113"/>
       <pc:docMkLst>
         <pc:docMk/>
       </pc:docMkLst>
       <pc:sldChg chg="modSp mod">
-        <pc:chgData name="Sai Nikitha" userId="c9bca8b270492e35" providerId="LiveId" clId="{AABBDE1E-0FB9-4CB6-9955-FC440C73D552}" dt="2026-06-08T15:34:28.931" v="70" actId="404"/>
+        <pc:chgData name="Sai Nikitha" userId="c9bca8b270492e35" providerId="LiveId" clId="{AABBDE1E-0FB9-4CB6-9955-FC440C73D552}" dt="2026-06-19T15:15:39.549" v="272" actId="113"/>
         <pc:sldMkLst>
           <pc:docMk/>
           <pc:sldMk cId="2677066207" sldId="257"/>
         </pc:sldMkLst>
         <pc:spChg chg="mod">
-          <ac:chgData name="Sai Nikitha" userId="c9bca8b270492e35" providerId="LiveId" clId="{AABBDE1E-0FB9-4CB6-9955-FC440C73D552}" dt="2026-06-08T15:34:28.931" v="70" actId="404"/>
+          <ac:chgData name="Sai Nikitha" userId="c9bca8b270492e35" providerId="LiveId" clId="{AABBDE1E-0FB9-4CB6-9955-FC440C73D552}" dt="2026-06-19T15:15:39.549" v="272" actId="113"/>
           <ac:spMkLst>
             <pc:docMk/>
             <pc:sldMk cId="2677066207" sldId="257"/>
@@ -240,34 +240,6 @@
           </ac:spMkLst>
         </pc:spChg>
       </pc:sldChg>
-      <pc:sldChg chg="del">
-        <pc:chgData name="Sai Nikitha" userId="c9bca8b270492e35" providerId="LiveId" clId="{AABBDE1E-0FB9-4CB6-9955-FC440C73D552}" dt="2026-06-08T15:44:54.245" v="243" actId="47"/>
-        <pc:sldMkLst>
-          <pc:docMk/>
-          <pc:sldMk cId="3979719745" sldId="264"/>
-        </pc:sldMkLst>
-      </pc:sldChg>
-      <pc:sldChg chg="del">
-        <pc:chgData name="Sai Nikitha" userId="c9bca8b270492e35" providerId="LiveId" clId="{AABBDE1E-0FB9-4CB6-9955-FC440C73D552}" dt="2026-06-08T15:44:57.971" v="244" actId="47"/>
-        <pc:sldMkLst>
-          <pc:docMk/>
-          <pc:sldMk cId="3753186587" sldId="265"/>
-        </pc:sldMkLst>
-      </pc:sldChg>
-      <pc:sldChg chg="del">
-        <pc:chgData name="Sai Nikitha" userId="c9bca8b270492e35" providerId="LiveId" clId="{AABBDE1E-0FB9-4CB6-9955-FC440C73D552}" dt="2026-06-08T15:45:01.394" v="245" actId="47"/>
-        <pc:sldMkLst>
-          <pc:docMk/>
-          <pc:sldMk cId="4255122284" sldId="266"/>
-        </pc:sldMkLst>
-      </pc:sldChg>
-      <pc:sldChg chg="del">
-        <pc:chgData name="Sai Nikitha" userId="c9bca8b270492e35" providerId="LiveId" clId="{AABBDE1E-0FB9-4CB6-9955-FC440C73D552}" dt="2026-06-08T15:45:03.585" v="246" actId="47"/>
-        <pc:sldMkLst>
-          <pc:docMk/>
-          <pc:sldMk cId="1531814548" sldId="267"/>
-        </pc:sldMkLst>
-      </pc:sldChg>
     </pc:docChg>
   </pc:docChgLst>
 </pc:chgInfo>
@@ -420,7 +392,7 @@
           <a:p>
             <a:fld id="{F60A69EA-BCAD-45CF-A2A8-AD306D85C5AE}" type="datetimeFigureOut">
               <a:rPr lang="en-US" smtClean="0"/>
-              <a:t>6/8/2026</a:t>
+              <a:t>6/19/2026</a:t>
             </a:fld>
             <a:endParaRPr lang="en-US"/>
           </a:p>
@@ -618,7 +590,7 @@
           <a:p>
             <a:fld id="{F60A69EA-BCAD-45CF-A2A8-AD306D85C5AE}" type="datetimeFigureOut">
               <a:rPr lang="en-US" smtClean="0"/>
-              <a:t>6/8/2026</a:t>
+              <a:t>6/19/2026</a:t>
             </a:fld>
             <a:endParaRPr lang="en-US"/>
           </a:p>
@@ -826,7 +798,7 @@
           <a:p>
             <a:fld id="{F60A69EA-BCAD-45CF-A2A8-AD306D85C5AE}" type="datetimeFigureOut">
               <a:rPr lang="en-US" smtClean="0"/>
-              <a:t>6/8/2026</a:t>
+              <a:t>6/19/2026</a:t>
             </a:fld>
             <a:endParaRPr lang="en-US"/>
           </a:p>
@@ -1024,7 +996,7 @@
           <a:p>
             <a:fld id="{F60A69EA-BCAD-45CF-A2A8-AD306D85C5AE}" type="datetimeFigureOut">
               <a:rPr lang="en-US" smtClean="0"/>
-              <a:t>6/8/2026</a:t>
+              <a:t>6/19/2026</a:t>
             </a:fld>
             <a:endParaRPr lang="en-US"/>
           </a:p>
@@ -1299,7 +1271,7 @@
           <a:p>
             <a:fld id="{F60A69EA-BCAD-45CF-A2A8-AD306D85C5AE}" type="datetimeFigureOut">
               <a:rPr lang="en-US" smtClean="0"/>
-              <a:t>6/8/2026</a:t>
+              <a:t>6/19/2026</a:t>
             </a:fld>
             <a:endParaRPr lang="en-US"/>
           </a:p>
@@ -1564,7 +1536,7 @@
           <a:p>
             <a:fld id="{F60A69EA-BCAD-45CF-A2A8-AD306D85C5AE}" type="datetimeFigureOut">
               <a:rPr lang="en-US" smtClean="0"/>
-              <a:t>6/8/2026</a:t>
+              <a:t>6/19/2026</a:t>
             </a:fld>
             <a:endParaRPr lang="en-US"/>
           </a:p>
@@ -1976,7 +1948,7 @@
           <a:p>
             <a:fld id="{F60A69EA-BCAD-45CF-A2A8-AD306D85C5AE}" type="datetimeFigureOut">
               <a:rPr lang="en-US" smtClean="0"/>
-              <a:t>6/8/2026</a:t>
+              <a:t>6/19/2026</a:t>
             </a:fld>
             <a:endParaRPr lang="en-US"/>
           </a:p>
@@ -2117,7 +2089,7 @@
           <a:p>
             <a:fld id="{F60A69EA-BCAD-45CF-A2A8-AD306D85C5AE}" type="datetimeFigureOut">
               <a:rPr lang="en-US" smtClean="0"/>
-              <a:t>6/8/2026</a:t>
+              <a:t>6/19/2026</a:t>
             </a:fld>
             <a:endParaRPr lang="en-US"/>
           </a:p>
@@ -2230,7 +2202,7 @@
           <a:p>
             <a:fld id="{F60A69EA-BCAD-45CF-A2A8-AD306D85C5AE}" type="datetimeFigureOut">
               <a:rPr lang="en-US" smtClean="0"/>
-              <a:t>6/8/2026</a:t>
+              <a:t>6/19/2026</a:t>
             </a:fld>
             <a:endParaRPr lang="en-US"/>
           </a:p>
@@ -2541,7 +2513,7 @@
           <a:p>
             <a:fld id="{F60A69EA-BCAD-45CF-A2A8-AD306D85C5AE}" type="datetimeFigureOut">
               <a:rPr lang="en-US" smtClean="0"/>
-              <a:t>6/8/2026</a:t>
+              <a:t>6/19/2026</a:t>
             </a:fld>
             <a:endParaRPr lang="en-US"/>
           </a:p>
@@ -2829,7 +2801,7 @@
           <a:p>
             <a:fld id="{F60A69EA-BCAD-45CF-A2A8-AD306D85C5AE}" type="datetimeFigureOut">
               <a:rPr lang="en-US" smtClean="0"/>
-              <a:t>6/8/2026</a:t>
+              <a:t>6/19/2026</a:t>
             </a:fld>
             <a:endParaRPr lang="en-US"/>
           </a:p>
@@ -3070,7 +3042,7 @@
           <a:p>
             <a:fld id="{F60A69EA-BCAD-45CF-A2A8-AD306D85C5AE}" type="datetimeFigureOut">
               <a:rPr lang="en-US" smtClean="0"/>
-              <a:t>6/8/2026</a:t>
+              <a:t>6/19/2026</a:t>
             </a:fld>
             <a:endParaRPr lang="en-US"/>
           </a:p>
@@ -3502,7 +3474,7 @@
         <p:spPr>
           <a:xfrm>
             <a:off x="0" y="97971"/>
-            <a:ext cx="12191999" cy="9110186"/>
+            <a:ext cx="12191999" cy="8617744"/>
           </a:xfrm>
           <a:prstGeom prst="rect">
             <a:avLst/>
@@ -3545,14 +3517,6 @@
             <a:endParaRPr lang="en-US" sz="2800" b="1" dirty="0"/>
           </a:p>
           <a:p>
-            <a:pPr algn="ctr"/>
-            <a:endParaRPr lang="en-US" sz="2800" b="1" dirty="0"/>
-          </a:p>
-          <a:p>
-            <a:pPr algn="ctr"/>
-            <a:endParaRPr lang="en-US" sz="2800" b="1" dirty="0"/>
-          </a:p>
-          <a:p>
             <a:r>
               <a:rPr lang="en-US" sz="2400" b="1" dirty="0"/>
               <a:t>Submitted By:</a:t>
@@ -3576,16 +3540,33 @@
           </a:p>
           <a:p>
             <a:r>
-              <a:rPr lang="en-US" sz="2400" dirty="0"/>
+              <a:rPr lang="en-US" sz="2400" dirty="0">
+                <a:hlinkClick r:id="rId2"/>
+              </a:rPr>
               <a:t>https://github.com/sainikitha7676/AI_ASSISTANT_PROJECT</a:t>
             </a:r>
-          </a:p>
-          <a:p>
-            <a:endParaRPr lang="en-US" sz="2800" b="1" dirty="0"/>
-          </a:p>
-          <a:p>
-            <a:pPr algn="ctr"/>
-            <a:endParaRPr lang="en-US" sz="2800" b="1" dirty="0"/>
+            <a:endParaRPr lang="en-US" sz="2400" dirty="0"/>
+          </a:p>
+          <a:p>
+            <a:endParaRPr lang="en-US" sz="2400" b="1" dirty="0"/>
+          </a:p>
+          <a:p>
+            <a:r>
+              <a:rPr lang="en-US" sz="2800" b="1" dirty="0"/>
+              <a:t>Deployed Link:</a:t>
+            </a:r>
+          </a:p>
+          <a:p>
+            <a:r>
+              <a:rPr lang="en-US" sz="2400" dirty="0">
+                <a:hlinkClick r:id="rId3"/>
+              </a:rPr>
+              <a:t>https://aiassistantproject--sainikithavytla.replit.app</a:t>
+            </a:r>
+            <a:endParaRPr lang="en-US" sz="2400" dirty="0"/>
+          </a:p>
+          <a:p>
+            <a:endParaRPr lang="en-US" sz="2000" b="1" dirty="0"/>
           </a:p>
           <a:p>
             <a:pPr algn="ctr"/>

</xml_diff>